<commit_message>
Update product overview for the shipped Reader portal, tighten exec summary
The Reader portal (published rosters + CSV/PDF export) is no longer a
Phase 4 placeholder, so both product-overview.html and .pptx now show
it as a fourth working portal:
- Portal map card drops "(planned)"; new feature section/slide with a
  real screenshot of the read-only detail view and export buttons
- Roadmap loses the now-shipped item (2 cards instead of 3)
- Budget table's Reader row reflects real CSV/PDF export value

Also rewrites the executive summary to be noticeably shorter and more
direct — three tight sentences instead of three long ones, updated to
say all four portals are live rather than three-plus-one-planned.

build-pptx.py regenerated to match (18 slides, was 17).
</commit_message>
<xml_diff>
--- a/frontend/public/introduction/product-overview.pptx
+++ b/frontend/public/introduction/product-overview.pptx
@@ -22,6 +22,7 @@
     <p:sldId id="270" r:id="rId21"/>
     <p:sldId id="271" r:id="rId22"/>
     <p:sldId id="272" r:id="rId23"/>
+    <p:sldId id="273" r:id="rId24"/>
   </p:sldIdLst>
   <p:sldSz cx="12191695" cy="6858000" type="screen4x3"/>
   <p:notesSz cx="6858000" cy="9144000"/>
@@ -4969,6 +4970,353 @@
             <a:avLst/>
           </a:prstGeom>
           <a:solidFill>
+            <a:srgbClr val="FFFFFF"/>
+          </a:solidFill>
+          <a:ln>
+            <a:noFill/>
+          </a:ln>
+          <a:effectLst/>
+        </p:spPr>
+        <p:style>
+          <a:lnRef idx="1">
+            <a:schemeClr val="accent1"/>
+          </a:lnRef>
+          <a:fillRef idx="3">
+            <a:schemeClr val="accent1"/>
+          </a:fillRef>
+          <a:effectRef idx="2">
+            <a:schemeClr val="accent1"/>
+          </a:effectRef>
+          <a:fontRef idx="minor">
+            <a:schemeClr val="lt1"/>
+          </a:fontRef>
+        </p:style>
+        <p:txBody>
+          <a:bodyPr rtlCol="0" anchor="ctr"/>
+          <a:lstStyle/>
+          <a:p>
+            <a:pPr algn="ctr"/>
+          </a:p>
+        </p:txBody>
+      </p:sp>
+      <p:pic>
+        <p:nvPicPr>
+          <p:cNvPr id="3" name="Picture 2" descr="reader-detail.png"/>
+          <p:cNvPicPr>
+            <a:picLocks noChangeAspect="1"/>
+          </p:cNvPicPr>
+          <p:nvPr/>
+        </p:nvPicPr>
+        <p:blipFill>
+          <a:blip r:embed="rId2"/>
+          <a:stretch>
+            <a:fillRect/>
+          </a:stretch>
+        </p:blipFill>
+        <p:spPr>
+          <a:xfrm>
+            <a:off x="640080" y="822960"/>
+            <a:ext cx="5074920" cy="3594735"/>
+          </a:xfrm>
+          <a:prstGeom prst="rect">
+            <a:avLst/>
+          </a:prstGeom>
+          <a:ln w="9525">
+            <a:solidFill>
+              <a:srgbClr val="E3E1DA"/>
+            </a:solidFill>
+          </a:ln>
+          <a:effectLst/>
+        </p:spPr>
+      </p:pic>
+      <p:sp>
+        <p:nvSpPr>
+          <p:cNvPr id="4" name="TextBox 3"/>
+          <p:cNvSpPr txBox="1"/>
+          <p:nvPr/>
+        </p:nvSpPr>
+        <p:spPr>
+          <a:xfrm>
+            <a:off x="640080" y="4509135"/>
+            <a:ext cx="5074920" cy="457200"/>
+          </a:xfrm>
+          <a:prstGeom prst="rect">
+            <a:avLst/>
+          </a:prstGeom>
+          <a:noFill/>
+        </p:spPr>
+        <p:txBody>
+          <a:bodyPr wrap="square" anchor="t">
+            <a:noAutofit/>
+          </a:bodyPr>
+          <a:lstStyle/>
+          <a:p>
+            <a:pPr algn="ctr"/>
+            <a:r>
+              <a:rPr sz="1000" b="0" i="1">
+                <a:solidFill>
+                  <a:srgbClr val="6B6B6B"/>
+                </a:solidFill>
+                <a:latin typeface="Arial"/>
+              </a:rPr>
+              <a:t>Read-only roster detail, with CSV and PDF export on every row</a:t>
+            </a:r>
+          </a:p>
+        </p:txBody>
+      </p:sp>
+      <p:sp>
+        <p:nvSpPr>
+          <p:cNvPr id="5" name="TextBox 4"/>
+          <p:cNvSpPr txBox="1"/>
+          <p:nvPr/>
+        </p:nvSpPr>
+        <p:spPr>
+          <a:xfrm>
+            <a:off x="6126480" y="685800"/>
+            <a:ext cx="5425135" cy="320040"/>
+          </a:xfrm>
+          <a:prstGeom prst="rect">
+            <a:avLst/>
+          </a:prstGeom>
+          <a:noFill/>
+        </p:spPr>
+        <p:txBody>
+          <a:bodyPr wrap="square" anchor="t">
+            <a:noAutofit/>
+          </a:bodyPr>
+          <a:lstStyle/>
+          <a:p>
+            <a:pPr algn="l"/>
+            <a:r>
+              <a:rPr sz="1050" b="1" i="0">
+                <a:solidFill>
+                  <a:srgbClr val="C9A84C"/>
+                </a:solidFill>
+                <a:latin typeface="Arial"/>
+              </a:rPr>
+              <a:t>READER · PUBLISHED ROSTERS</a:t>
+            </a:r>
+          </a:p>
+        </p:txBody>
+      </p:sp>
+      <p:sp>
+        <p:nvSpPr>
+          <p:cNvPr id="6" name="TextBox 5"/>
+          <p:cNvSpPr txBox="1"/>
+          <p:nvPr/>
+        </p:nvSpPr>
+        <p:spPr>
+          <a:xfrm>
+            <a:off x="6126480" y="1024128"/>
+            <a:ext cx="5425135" cy="1234440"/>
+          </a:xfrm>
+          <a:prstGeom prst="rect">
+            <a:avLst/>
+          </a:prstGeom>
+          <a:noFill/>
+        </p:spPr>
+        <p:txBody>
+          <a:bodyPr wrap="square" anchor="t">
+            <a:noAutofit/>
+          </a:bodyPr>
+          <a:lstStyle/>
+          <a:p>
+            <a:pPr algn="l">
+              <a:lnSpc>
+                <a:spcPct val="115000"/>
+              </a:lnSpc>
+            </a:pPr>
+            <a:r>
+              <a:rPr sz="2100" b="0" i="0">
+                <a:solidFill>
+                  <a:srgbClr val="1E2761"/>
+                </a:solidFill>
+                <a:latin typeface="Georgia"/>
+              </a:rPr>
+              <a:t>A shared screen or a printout, without a spreadsheet in between.</a:t>
+            </a:r>
+          </a:p>
+        </p:txBody>
+      </p:sp>
+      <p:sp>
+        <p:nvSpPr>
+          <p:cNvPr id="7" name="TextBox 6"/>
+          <p:cNvSpPr txBox="1"/>
+          <p:nvPr/>
+        </p:nvSpPr>
+        <p:spPr>
+          <a:xfrm>
+            <a:off x="6126480" y="2331720"/>
+            <a:ext cx="5425135" cy="1600200"/>
+          </a:xfrm>
+          <a:prstGeom prst="rect">
+            <a:avLst/>
+          </a:prstGeom>
+          <a:noFill/>
+        </p:spPr>
+        <p:txBody>
+          <a:bodyPr wrap="square" anchor="t">
+            <a:noAutofit/>
+          </a:bodyPr>
+          <a:lstStyle/>
+          <a:p>
+            <a:pPr algn="l">
+              <a:lnSpc>
+                <a:spcPct val="132000"/>
+              </a:lnSpc>
+            </a:pPr>
+            <a:r>
+              <a:rPr sz="1200" b="0" i="0">
+                <a:solidFill>
+                  <a:srgbClr val="6B6B6B"/>
+                </a:solidFill>
+                <a:latin typeface="Arial"/>
+              </a:rPr>
+              <a:t>Lists every published roster for its boutique and expands to the identical staff-mix and rule-flag detail view admins and approvers see, minus any edit controls. Every row exports straight to CSV or a print-ready PDF.</a:t>
+            </a:r>
+          </a:p>
+        </p:txBody>
+      </p:sp>
+      <p:sp>
+        <p:nvSpPr>
+          <p:cNvPr id="8" name="TextBox 7"/>
+          <p:cNvSpPr txBox="1"/>
+          <p:nvPr/>
+        </p:nvSpPr>
+        <p:spPr>
+          <a:xfrm>
+            <a:off x="6126480" y="4069080"/>
+            <a:ext cx="5425135" cy="2194560"/>
+          </a:xfrm>
+          <a:prstGeom prst="rect">
+            <a:avLst/>
+          </a:prstGeom>
+          <a:noFill/>
+        </p:spPr>
+        <p:txBody>
+          <a:bodyPr wrap="square">
+            <a:noAutofit/>
+          </a:bodyPr>
+          <a:lstStyle/>
+          <a:p>
+            <a:pPr>
+              <a:lnSpc>
+                <a:spcPct val="118000"/>
+              </a:lnSpc>
+              <a:spcAft>
+                <a:spcPts val="900"/>
+              </a:spcAft>
+            </a:pPr>
+            <a:r>
+              <a:rPr sz="1150">
+                <a:solidFill>
+                  <a:srgbClr val="C9A84C"/>
+                </a:solidFill>
+                <a:latin typeface="Arial"/>
+              </a:rPr>
+              <a:t>✦  </a:t>
+            </a:r>
+            <a:r>
+              <a:rPr sz="1150">
+                <a:solidFill>
+                  <a:srgbClr val="1A1A1A"/>
+                </a:solidFill>
+                <a:latin typeface="Arial"/>
+              </a:rPr>
+              <a:t>Shows published rosters only — drafts and pending approvals stay invisible</a:t>
+            </a:r>
+          </a:p>
+          <a:p>
+            <a:pPr>
+              <a:lnSpc>
+                <a:spcPct val="118000"/>
+              </a:lnSpc>
+              <a:spcAft>
+                <a:spcPts val="900"/>
+              </a:spcAft>
+            </a:pPr>
+            <a:r>
+              <a:rPr sz="1150">
+                <a:solidFill>
+                  <a:srgbClr val="C9A84C"/>
+                </a:solidFill>
+                <a:latin typeface="Arial"/>
+              </a:rPr>
+              <a:t>✦  </a:t>
+            </a:r>
+            <a:r>
+              <a:rPr sz="1150">
+                <a:solidFill>
+                  <a:srgbClr val="1A1A1A"/>
+                </a:solidFill>
+                <a:latin typeface="Arial"/>
+              </a:rPr>
+              <a:t>One-click CSV export for downstream systems, PDF for printing or a shared screen</a:t>
+            </a:r>
+          </a:p>
+          <a:p>
+            <a:pPr>
+              <a:lnSpc>
+                <a:spcPct val="118000"/>
+              </a:lnSpc>
+              <a:spcAft>
+                <a:spcPts val="900"/>
+              </a:spcAft>
+            </a:pPr>
+            <a:r>
+              <a:rPr sz="1150">
+                <a:solidFill>
+                  <a:srgbClr val="C9A84C"/>
+                </a:solidFill>
+                <a:latin typeface="Arial"/>
+              </a:rPr>
+              <a:t>✦  </a:t>
+            </a:r>
+            <a:r>
+              <a:rPr sz="1150">
+                <a:solidFill>
+                  <a:srgbClr val="1A1A1A"/>
+                </a:solidFill>
+                <a:latin typeface="Arial"/>
+              </a:rPr>
+              <a:t>No admin or approver access required — a login scoped to one boutique, read-only</a:t>
+            </a:r>
+          </a:p>
+        </p:txBody>
+      </p:sp>
+    </p:spTree>
+  </p:cSld>
+  <p:clrMapOvr>
+    <a:masterClrMapping/>
+  </p:clrMapOvr>
+</p:sld>
+</file>
+
+<file path=ppt/slides/slide15.xml><?xml version="1.0" encoding="utf-8"?>
+<p:sld xmlns:a="http://schemas.openxmlformats.org/drawingml/2006/main" xmlns:p="http://schemas.openxmlformats.org/presentationml/2006/main" xmlns:r="http://schemas.openxmlformats.org/officeDocument/2006/relationships">
+  <p:cSld>
+    <p:spTree>
+      <p:nvGrpSpPr>
+        <p:cNvPr id="1" name=""/>
+        <p:cNvGrpSpPr/>
+        <p:nvPr/>
+      </p:nvGrpSpPr>
+      <p:grpSpPr/>
+      <p:sp>
+        <p:nvSpPr>
+          <p:cNvPr id="2" name="Rectangle 1"/>
+          <p:cNvSpPr/>
+          <p:nvPr/>
+        </p:nvSpPr>
+        <p:spPr>
+          <a:xfrm>
+            <a:off x="0" y="0"/>
+            <a:ext cx="12191695" cy="6858000"/>
+          </a:xfrm>
+          <a:prstGeom prst="rect">
+            <a:avLst/>
+          </a:prstGeom>
+          <a:solidFill>
             <a:srgbClr val="F5F0E8"/>
           </a:solidFill>
           <a:ln>
@@ -6033,7 +6381,7 @@
 </p:sld>
 </file>
 
-<file path=ppt/slides/slide15.xml><?xml version="1.0" encoding="utf-8"?>
+<file path=ppt/slides/slide16.xml><?xml version="1.0" encoding="utf-8"?>
 <p:sld xmlns:a="http://schemas.openxmlformats.org/drawingml/2006/main" xmlns:p="http://schemas.openxmlformats.org/presentationml/2006/main" xmlns:r="http://schemas.openxmlformats.org/officeDocument/2006/relationships">
   <p:cSld>
     <p:spTree>
@@ -6726,7 +7074,7 @@
                           </a:solidFill>
                           <a:latin typeface="Arial"/>
                         </a:rPr>
-                        <a:t>Published Rosters — planned</a:t>
+                        <a:t>Published Rosters</a:t>
                       </a:r>
                     </a:p>
                   </a:txBody>
@@ -6780,7 +7128,7 @@
                           </a:solidFill>
                           <a:latin typeface="Arial"/>
                         </a:rPr>
-                        <a:t>Printed roster taped to a wall</a:t>
+                        <a:t>Printed roster taped to a wall, manual CSV exports</a:t>
                       </a:r>
                     </a:p>
                   </a:txBody>
@@ -6807,7 +7155,7 @@
                           </a:solidFill>
                           <a:latin typeface="Arial"/>
                         </a:rPr>
-                        <a:t>Always-current view with no reprint cycle once delivered</a:t>
+                        <a:t>Always-current view, plus one-click CSV/PDF export, with no reprint cycle</a:t>
                       </a:r>
                     </a:p>
                   </a:txBody>
@@ -7262,722 +7610,6 @@
                 <a:latin typeface="Arial"/>
               </a:rPr>
               <a:t>Auto-deploy on every change</a:t>
-            </a:r>
-          </a:p>
-        </p:txBody>
-      </p:sp>
-    </p:spTree>
-  </p:cSld>
-  <p:clrMapOvr>
-    <a:masterClrMapping/>
-  </p:clrMapOvr>
-</p:sld>
-</file>
-
-<file path=ppt/slides/slide16.xml><?xml version="1.0" encoding="utf-8"?>
-<p:sld xmlns:a="http://schemas.openxmlformats.org/drawingml/2006/main" xmlns:p="http://schemas.openxmlformats.org/presentationml/2006/main" xmlns:r="http://schemas.openxmlformats.org/officeDocument/2006/relationships">
-  <p:cSld>
-    <p:spTree>
-      <p:nvGrpSpPr>
-        <p:cNvPr id="1" name=""/>
-        <p:cNvGrpSpPr/>
-        <p:nvPr/>
-      </p:nvGrpSpPr>
-      <p:grpSpPr/>
-      <p:sp>
-        <p:nvSpPr>
-          <p:cNvPr id="2" name="Rectangle 1"/>
-          <p:cNvSpPr/>
-          <p:nvPr/>
-        </p:nvSpPr>
-        <p:spPr>
-          <a:xfrm>
-            <a:off x="0" y="0"/>
-            <a:ext cx="12191695" cy="6858000"/>
-          </a:xfrm>
-          <a:prstGeom prst="rect">
-            <a:avLst/>
-          </a:prstGeom>
-          <a:solidFill>
-            <a:srgbClr val="F5F0E8"/>
-          </a:solidFill>
-          <a:ln>
-            <a:noFill/>
-          </a:ln>
-          <a:effectLst/>
-        </p:spPr>
-        <p:style>
-          <a:lnRef idx="1">
-            <a:schemeClr val="accent1"/>
-          </a:lnRef>
-          <a:fillRef idx="3">
-            <a:schemeClr val="accent1"/>
-          </a:fillRef>
-          <a:effectRef idx="2">
-            <a:schemeClr val="accent1"/>
-          </a:effectRef>
-          <a:fontRef idx="minor">
-            <a:schemeClr val="lt1"/>
-          </a:fontRef>
-        </p:style>
-        <p:txBody>
-          <a:bodyPr rtlCol="0" anchor="ctr"/>
-          <a:lstStyle/>
-          <a:p>
-            <a:pPr algn="ctr"/>
-          </a:p>
-        </p:txBody>
-      </p:sp>
-      <p:sp>
-        <p:nvSpPr>
-          <p:cNvPr id="3" name="TextBox 2"/>
-          <p:cNvSpPr txBox="1"/>
-          <p:nvPr/>
-        </p:nvSpPr>
-        <p:spPr>
-          <a:xfrm>
-            <a:off x="640080" y="457200"/>
-            <a:ext cx="7315200" cy="274320"/>
-          </a:xfrm>
-          <a:prstGeom prst="rect">
-            <a:avLst/>
-          </a:prstGeom>
-          <a:noFill/>
-        </p:spPr>
-        <p:txBody>
-          <a:bodyPr wrap="square" anchor="t">
-            <a:noAutofit/>
-          </a:bodyPr>
-          <a:lstStyle/>
-          <a:p>
-            <a:pPr algn="l"/>
-            <a:r>
-              <a:rPr sz="1100" b="1" i="0">
-                <a:solidFill>
-                  <a:srgbClr val="C9A84C"/>
-                </a:solidFill>
-                <a:latin typeface="Arial"/>
-              </a:rPr>
-              <a:t>WHAT'S NEXT</a:t>
-            </a:r>
-          </a:p>
-        </p:txBody>
-      </p:sp>
-      <p:sp>
-        <p:nvSpPr>
-          <p:cNvPr id="4" name="TextBox 3"/>
-          <p:cNvSpPr txBox="1"/>
-          <p:nvPr/>
-        </p:nvSpPr>
-        <p:spPr>
-          <a:xfrm>
-            <a:off x="640080" y="777240"/>
-            <a:ext cx="10911535" cy="1005840"/>
-          </a:xfrm>
-          <a:prstGeom prst="rect">
-            <a:avLst/>
-          </a:prstGeom>
-          <a:noFill/>
-        </p:spPr>
-        <p:txBody>
-          <a:bodyPr wrap="square" anchor="t">
-            <a:noAutofit/>
-          </a:bodyPr>
-          <a:lstStyle/>
-          <a:p>
-            <a:pPr algn="l"/>
-            <a:r>
-              <a:rPr sz="2600" b="0" i="0">
-                <a:solidFill>
-                  <a:srgbClr val="1E2761"/>
-                </a:solidFill>
-                <a:latin typeface="Georgia"/>
-              </a:rPr>
-              <a:t>Scoped, not hidden.</a:t>
-            </a:r>
-          </a:p>
-        </p:txBody>
-      </p:sp>
-      <p:sp>
-        <p:nvSpPr>
-          <p:cNvPr id="5" name="TextBox 4"/>
-          <p:cNvSpPr txBox="1"/>
-          <p:nvPr/>
-        </p:nvSpPr>
-        <p:spPr>
-          <a:xfrm>
-            <a:off x="640080" y="1508760"/>
-            <a:ext cx="10911535" cy="457200"/>
-          </a:xfrm>
-          <a:prstGeom prst="rect">
-            <a:avLst/>
-          </a:prstGeom>
-          <a:noFill/>
-        </p:spPr>
-        <p:txBody>
-          <a:bodyPr wrap="square" anchor="t">
-            <a:noAutofit/>
-          </a:bodyPr>
-          <a:lstStyle/>
-          <a:p>
-            <a:pPr algn="l"/>
-            <a:r>
-              <a:rPr sz="1250" b="0" i="0">
-                <a:solidFill>
-                  <a:srgbClr val="6B6B6B"/>
-                </a:solidFill>
-                <a:latin typeface="Arial"/>
-              </a:rPr>
-              <a:t>A few screens are intentionally stubbed for a later phase rather than rushed — worth knowing for planning purposes.</a:t>
-            </a:r>
-          </a:p>
-        </p:txBody>
-      </p:sp>
-      <p:sp>
-        <p:nvSpPr>
-          <p:cNvPr id="6" name="Rounded Rectangle 5"/>
-          <p:cNvSpPr/>
-          <p:nvPr/>
-        </p:nvSpPr>
-        <p:spPr>
-          <a:xfrm>
-            <a:off x="640080" y="2286000"/>
-            <a:ext cx="3454298" cy="2377440"/>
-          </a:xfrm>
-          <a:prstGeom prst="roundRect">
-            <a:avLst>
-              <a:gd name="adj" fmla="val 6000"/>
-            </a:avLst>
-          </a:prstGeom>
-          <a:solidFill>
-            <a:srgbClr val="FFFFFF"/>
-          </a:solidFill>
-          <a:ln w="9525">
-            <a:solidFill>
-              <a:srgbClr val="E3E1DA"/>
-            </a:solidFill>
-          </a:ln>
-          <a:effectLst/>
-        </p:spPr>
-        <p:style>
-          <a:lnRef idx="1">
-            <a:schemeClr val="accent1"/>
-          </a:lnRef>
-          <a:fillRef idx="3">
-            <a:schemeClr val="accent1"/>
-          </a:fillRef>
-          <a:effectRef idx="2">
-            <a:schemeClr val="accent1"/>
-          </a:effectRef>
-          <a:fontRef idx="minor">
-            <a:schemeClr val="lt1"/>
-          </a:fontRef>
-        </p:style>
-        <p:txBody>
-          <a:bodyPr rtlCol="0" anchor="ctr"/>
-          <a:lstStyle/>
-          <a:p>
-            <a:pPr algn="ctr"/>
-          </a:p>
-        </p:txBody>
-      </p:sp>
-      <p:sp>
-        <p:nvSpPr>
-          <p:cNvPr id="7" name="Rounded Rectangle 6"/>
-          <p:cNvSpPr/>
-          <p:nvPr/>
-        </p:nvSpPr>
-        <p:spPr>
-          <a:xfrm>
-            <a:off x="868680" y="2514600"/>
-            <a:ext cx="636422" cy="256032"/>
-          </a:xfrm>
-          <a:prstGeom prst="roundRect">
-            <a:avLst>
-              <a:gd name="adj" fmla="val 50000"/>
-            </a:avLst>
-          </a:prstGeom>
-          <a:solidFill>
-            <a:srgbClr val="FDF0DD"/>
-          </a:solidFill>
-          <a:ln>
-            <a:noFill/>
-          </a:ln>
-          <a:effectLst/>
-        </p:spPr>
-        <p:style>
-          <a:lnRef idx="1">
-            <a:schemeClr val="accent1"/>
-          </a:lnRef>
-          <a:fillRef idx="3">
-            <a:schemeClr val="accent1"/>
-          </a:fillRef>
-          <a:effectRef idx="2">
-            <a:schemeClr val="accent1"/>
-          </a:effectRef>
-          <a:fontRef idx="minor">
-            <a:schemeClr val="lt1"/>
-          </a:fontRef>
-        </p:style>
-        <p:txBody>
-          <a:bodyPr rtlCol="0" anchor="ctr" lIns="50800" rIns="50800" tIns="12700" bIns="12700">
-            <a:noAutofit/>
-          </a:bodyPr>
-          <a:lstStyle/>
-          <a:p>
-            <a:pPr algn="ctr"/>
-            <a:r>
-              <a:rPr sz="900" b="1">
-                <a:solidFill>
-                  <a:srgbClr val="8A5A12"/>
-                </a:solidFill>
-                <a:latin typeface="Arial"/>
-              </a:rPr>
-              <a:t>PHASE 4</a:t>
-            </a:r>
-          </a:p>
-        </p:txBody>
-      </p:sp>
-      <p:sp>
-        <p:nvSpPr>
-          <p:cNvPr id="8" name="TextBox 7"/>
-          <p:cNvSpPr txBox="1"/>
-          <p:nvPr/>
-        </p:nvSpPr>
-        <p:spPr>
-          <a:xfrm>
-            <a:off x="868680" y="2971800"/>
-            <a:ext cx="2997098" cy="731520"/>
-          </a:xfrm>
-          <a:prstGeom prst="rect">
-            <a:avLst/>
-          </a:prstGeom>
-          <a:noFill/>
-        </p:spPr>
-        <p:txBody>
-          <a:bodyPr wrap="square" anchor="t">
-            <a:noAutofit/>
-          </a:bodyPr>
-          <a:lstStyle/>
-          <a:p>
-            <a:pPr algn="l">
-              <a:lnSpc>
-                <a:spcPct val="115000"/>
-              </a:lnSpc>
-            </a:pPr>
-            <a:r>
-              <a:rPr sz="1450" b="1" i="0">
-                <a:solidFill>
-                  <a:srgbClr val="1E2761"/>
-                </a:solidFill>
-                <a:latin typeface="Arial"/>
-              </a:rPr>
-              <a:t>Staff leave requests</a:t>
-            </a:r>
-          </a:p>
-        </p:txBody>
-      </p:sp>
-      <p:sp>
-        <p:nvSpPr>
-          <p:cNvPr id="9" name="TextBox 8"/>
-          <p:cNvSpPr txBox="1"/>
-          <p:nvPr/>
-        </p:nvSpPr>
-        <p:spPr>
-          <a:xfrm>
-            <a:off x="868680" y="3703320"/>
-            <a:ext cx="2997098" cy="822960"/>
-          </a:xfrm>
-          <a:prstGeom prst="rect">
-            <a:avLst/>
-          </a:prstGeom>
-          <a:noFill/>
-        </p:spPr>
-        <p:txBody>
-          <a:bodyPr wrap="square" anchor="t">
-            <a:noAutofit/>
-          </a:bodyPr>
-          <a:lstStyle/>
-          <a:p>
-            <a:pPr algn="l">
-              <a:lnSpc>
-                <a:spcPct val="130000"/>
-              </a:lnSpc>
-            </a:pPr>
-            <a:r>
-              <a:rPr sz="1100" b="0" i="0">
-                <a:solidFill>
-                  <a:srgbClr val="6B6B6B"/>
-                </a:solidFill>
-                <a:latin typeface="Arial"/>
-              </a:rPr>
-              <a:t>Let employees submit their own unavailability instead of going through an admin.</a:t>
-            </a:r>
-          </a:p>
-        </p:txBody>
-      </p:sp>
-      <p:sp>
-        <p:nvSpPr>
-          <p:cNvPr id="10" name="Rounded Rectangle 9"/>
-          <p:cNvSpPr/>
-          <p:nvPr/>
-        </p:nvSpPr>
-        <p:spPr>
-          <a:xfrm>
-            <a:off x="4368698" y="2286000"/>
-            <a:ext cx="3454298" cy="2377440"/>
-          </a:xfrm>
-          <a:prstGeom prst="roundRect">
-            <a:avLst>
-              <a:gd name="adj" fmla="val 6000"/>
-            </a:avLst>
-          </a:prstGeom>
-          <a:solidFill>
-            <a:srgbClr val="FFFFFF"/>
-          </a:solidFill>
-          <a:ln w="9525">
-            <a:solidFill>
-              <a:srgbClr val="E3E1DA"/>
-            </a:solidFill>
-          </a:ln>
-          <a:effectLst/>
-        </p:spPr>
-        <p:style>
-          <a:lnRef idx="1">
-            <a:schemeClr val="accent1"/>
-          </a:lnRef>
-          <a:fillRef idx="3">
-            <a:schemeClr val="accent1"/>
-          </a:fillRef>
-          <a:effectRef idx="2">
-            <a:schemeClr val="accent1"/>
-          </a:effectRef>
-          <a:fontRef idx="minor">
-            <a:schemeClr val="lt1"/>
-          </a:fontRef>
-        </p:style>
-        <p:txBody>
-          <a:bodyPr rtlCol="0" anchor="ctr"/>
-          <a:lstStyle/>
-          <a:p>
-            <a:pPr algn="ctr"/>
-          </a:p>
-        </p:txBody>
-      </p:sp>
-      <p:sp>
-        <p:nvSpPr>
-          <p:cNvPr id="11" name="Rounded Rectangle 10"/>
-          <p:cNvSpPr/>
-          <p:nvPr/>
-        </p:nvSpPr>
-        <p:spPr>
-          <a:xfrm>
-            <a:off x="4597298" y="2514600"/>
-            <a:ext cx="636422" cy="256032"/>
-          </a:xfrm>
-          <a:prstGeom prst="roundRect">
-            <a:avLst>
-              <a:gd name="adj" fmla="val 50000"/>
-            </a:avLst>
-          </a:prstGeom>
-          <a:solidFill>
-            <a:srgbClr val="FDF0DD"/>
-          </a:solidFill>
-          <a:ln>
-            <a:noFill/>
-          </a:ln>
-          <a:effectLst/>
-        </p:spPr>
-        <p:style>
-          <a:lnRef idx="1">
-            <a:schemeClr val="accent1"/>
-          </a:lnRef>
-          <a:fillRef idx="3">
-            <a:schemeClr val="accent1"/>
-          </a:fillRef>
-          <a:effectRef idx="2">
-            <a:schemeClr val="accent1"/>
-          </a:effectRef>
-          <a:fontRef idx="minor">
-            <a:schemeClr val="lt1"/>
-          </a:fontRef>
-        </p:style>
-        <p:txBody>
-          <a:bodyPr rtlCol="0" anchor="ctr" lIns="50800" rIns="50800" tIns="12700" bIns="12700">
-            <a:noAutofit/>
-          </a:bodyPr>
-          <a:lstStyle/>
-          <a:p>
-            <a:pPr algn="ctr"/>
-            <a:r>
-              <a:rPr sz="900" b="1">
-                <a:solidFill>
-                  <a:srgbClr val="8A5A12"/>
-                </a:solidFill>
-                <a:latin typeface="Arial"/>
-              </a:rPr>
-              <a:t>PHASE 4</a:t>
-            </a:r>
-          </a:p>
-        </p:txBody>
-      </p:sp>
-      <p:sp>
-        <p:nvSpPr>
-          <p:cNvPr id="12" name="TextBox 11"/>
-          <p:cNvSpPr txBox="1"/>
-          <p:nvPr/>
-        </p:nvSpPr>
-        <p:spPr>
-          <a:xfrm>
-            <a:off x="4597298" y="2971800"/>
-            <a:ext cx="2997098" cy="731520"/>
-          </a:xfrm>
-          <a:prstGeom prst="rect">
-            <a:avLst/>
-          </a:prstGeom>
-          <a:noFill/>
-        </p:spPr>
-        <p:txBody>
-          <a:bodyPr wrap="square" anchor="t">
-            <a:noAutofit/>
-          </a:bodyPr>
-          <a:lstStyle/>
-          <a:p>
-            <a:pPr algn="l">
-              <a:lnSpc>
-                <a:spcPct val="115000"/>
-              </a:lnSpc>
-            </a:pPr>
-            <a:r>
-              <a:rPr sz="1450" b="1" i="0">
-                <a:solidFill>
-                  <a:srgbClr val="1E2761"/>
-                </a:solidFill>
-                <a:latin typeface="Arial"/>
-              </a:rPr>
-              <a:t>Team view for staff</a:t>
-            </a:r>
-          </a:p>
-        </p:txBody>
-      </p:sp>
-      <p:sp>
-        <p:nvSpPr>
-          <p:cNvPr id="13" name="TextBox 12"/>
-          <p:cNvSpPr txBox="1"/>
-          <p:nvPr/>
-        </p:nvSpPr>
-        <p:spPr>
-          <a:xfrm>
-            <a:off x="4597298" y="3703320"/>
-            <a:ext cx="2997098" cy="822960"/>
-          </a:xfrm>
-          <a:prstGeom prst="rect">
-            <a:avLst/>
-          </a:prstGeom>
-          <a:noFill/>
-        </p:spPr>
-        <p:txBody>
-          <a:bodyPr wrap="square" anchor="t">
-            <a:noAutofit/>
-          </a:bodyPr>
-          <a:lstStyle/>
-          <a:p>
-            <a:pPr algn="l">
-              <a:lnSpc>
-                <a:spcPct val="130000"/>
-              </a:lnSpc>
-            </a:pPr>
-            <a:r>
-              <a:rPr sz="1100" b="0" i="0">
-                <a:solidFill>
-                  <a:srgbClr val="6B6B6B"/>
-                </a:solidFill>
-                <a:latin typeface="Arial"/>
-              </a:rPr>
-              <a:t>Let staff see the published roster for their whole boutique, not just their own shifts.</a:t>
-            </a:r>
-          </a:p>
-        </p:txBody>
-      </p:sp>
-      <p:sp>
-        <p:nvSpPr>
-          <p:cNvPr id="14" name="Rounded Rectangle 13"/>
-          <p:cNvSpPr/>
-          <p:nvPr/>
-        </p:nvSpPr>
-        <p:spPr>
-          <a:xfrm>
-            <a:off x="8097316" y="2286000"/>
-            <a:ext cx="3454298" cy="2377440"/>
-          </a:xfrm>
-          <a:prstGeom prst="roundRect">
-            <a:avLst>
-              <a:gd name="adj" fmla="val 6000"/>
-            </a:avLst>
-          </a:prstGeom>
-          <a:solidFill>
-            <a:srgbClr val="FFFFFF"/>
-          </a:solidFill>
-          <a:ln w="9525">
-            <a:solidFill>
-              <a:srgbClr val="E3E1DA"/>
-            </a:solidFill>
-          </a:ln>
-          <a:effectLst/>
-        </p:spPr>
-        <p:style>
-          <a:lnRef idx="1">
-            <a:schemeClr val="accent1"/>
-          </a:lnRef>
-          <a:fillRef idx="3">
-            <a:schemeClr val="accent1"/>
-          </a:fillRef>
-          <a:effectRef idx="2">
-            <a:schemeClr val="accent1"/>
-          </a:effectRef>
-          <a:fontRef idx="minor">
-            <a:schemeClr val="lt1"/>
-          </a:fontRef>
-        </p:style>
-        <p:txBody>
-          <a:bodyPr rtlCol="0" anchor="ctr"/>
-          <a:lstStyle/>
-          <a:p>
-            <a:pPr algn="ctr"/>
-          </a:p>
-        </p:txBody>
-      </p:sp>
-      <p:sp>
-        <p:nvSpPr>
-          <p:cNvPr id="15" name="Rounded Rectangle 14"/>
-          <p:cNvSpPr/>
-          <p:nvPr/>
-        </p:nvSpPr>
-        <p:spPr>
-          <a:xfrm>
-            <a:off x="8325916" y="2514600"/>
-            <a:ext cx="636422" cy="256032"/>
-          </a:xfrm>
-          <a:prstGeom prst="roundRect">
-            <a:avLst>
-              <a:gd name="adj" fmla="val 50000"/>
-            </a:avLst>
-          </a:prstGeom>
-          <a:solidFill>
-            <a:srgbClr val="FDF0DD"/>
-          </a:solidFill>
-          <a:ln>
-            <a:noFill/>
-          </a:ln>
-          <a:effectLst/>
-        </p:spPr>
-        <p:style>
-          <a:lnRef idx="1">
-            <a:schemeClr val="accent1"/>
-          </a:lnRef>
-          <a:fillRef idx="3">
-            <a:schemeClr val="accent1"/>
-          </a:fillRef>
-          <a:effectRef idx="2">
-            <a:schemeClr val="accent1"/>
-          </a:effectRef>
-          <a:fontRef idx="minor">
-            <a:schemeClr val="lt1"/>
-          </a:fontRef>
-        </p:style>
-        <p:txBody>
-          <a:bodyPr rtlCol="0" anchor="ctr" lIns="50800" rIns="50800" tIns="12700" bIns="12700">
-            <a:noAutofit/>
-          </a:bodyPr>
-          <a:lstStyle/>
-          <a:p>
-            <a:pPr algn="ctr"/>
-            <a:r>
-              <a:rPr sz="900" b="1">
-                <a:solidFill>
-                  <a:srgbClr val="8A5A12"/>
-                </a:solidFill>
-                <a:latin typeface="Arial"/>
-              </a:rPr>
-              <a:t>PHASE 4</a:t>
-            </a:r>
-          </a:p>
-        </p:txBody>
-      </p:sp>
-      <p:sp>
-        <p:nvSpPr>
-          <p:cNvPr id="16" name="TextBox 15"/>
-          <p:cNvSpPr txBox="1"/>
-          <p:nvPr/>
-        </p:nvSpPr>
-        <p:spPr>
-          <a:xfrm>
-            <a:off x="8325916" y="2971800"/>
-            <a:ext cx="2997098" cy="731520"/>
-          </a:xfrm>
-          <a:prstGeom prst="rect">
-            <a:avLst/>
-          </a:prstGeom>
-          <a:noFill/>
-        </p:spPr>
-        <p:txBody>
-          <a:bodyPr wrap="square" anchor="t">
-            <a:noAutofit/>
-          </a:bodyPr>
-          <a:lstStyle/>
-          <a:p>
-            <a:pPr algn="l">
-              <a:lnSpc>
-                <a:spcPct val="115000"/>
-              </a:lnSpc>
-            </a:pPr>
-            <a:r>
-              <a:rPr sz="1450" b="1" i="0">
-                <a:solidFill>
-                  <a:srgbClr val="1E2761"/>
-                </a:solidFill>
-                <a:latin typeface="Arial"/>
-              </a:rPr>
-              <a:t>Reader / published-roster browser</a:t>
-            </a:r>
-          </a:p>
-        </p:txBody>
-      </p:sp>
-      <p:sp>
-        <p:nvSpPr>
-          <p:cNvPr id="17" name="TextBox 16"/>
-          <p:cNvSpPr txBox="1"/>
-          <p:nvPr/>
-        </p:nvSpPr>
-        <p:spPr>
-          <a:xfrm>
-            <a:off x="8325916" y="3703320"/>
-            <a:ext cx="2997098" cy="822960"/>
-          </a:xfrm>
-          <a:prstGeom prst="rect">
-            <a:avLst/>
-          </a:prstGeom>
-          <a:noFill/>
-        </p:spPr>
-        <p:txBody>
-          <a:bodyPr wrap="square" anchor="t">
-            <a:noAutofit/>
-          </a:bodyPr>
-          <a:lstStyle/>
-          <a:p>
-            <a:pPr algn="l">
-              <a:lnSpc>
-                <a:spcPct val="130000"/>
-              </a:lnSpc>
-            </a:pPr>
-            <a:r>
-              <a:rPr sz="1100" b="0" i="0">
-                <a:solidFill>
-                  <a:srgbClr val="6B6B6B"/>
-                </a:solidFill>
-                <a:latin typeface="Arial"/>
-              </a:rPr>
-              <a:t>Read-only roster browsing with PDF/CSV export for shared displays and print.</a:t>
             </a:r>
           </a:p>
         </p:txBody>
@@ -8015,6 +7647,539 @@
             <a:avLst/>
           </a:prstGeom>
           <a:solidFill>
+            <a:srgbClr val="F5F0E8"/>
+          </a:solidFill>
+          <a:ln>
+            <a:noFill/>
+          </a:ln>
+          <a:effectLst/>
+        </p:spPr>
+        <p:style>
+          <a:lnRef idx="1">
+            <a:schemeClr val="accent1"/>
+          </a:lnRef>
+          <a:fillRef idx="3">
+            <a:schemeClr val="accent1"/>
+          </a:fillRef>
+          <a:effectRef idx="2">
+            <a:schemeClr val="accent1"/>
+          </a:effectRef>
+          <a:fontRef idx="minor">
+            <a:schemeClr val="lt1"/>
+          </a:fontRef>
+        </p:style>
+        <p:txBody>
+          <a:bodyPr rtlCol="0" anchor="ctr"/>
+          <a:lstStyle/>
+          <a:p>
+            <a:pPr algn="ctr"/>
+          </a:p>
+        </p:txBody>
+      </p:sp>
+      <p:sp>
+        <p:nvSpPr>
+          <p:cNvPr id="3" name="TextBox 2"/>
+          <p:cNvSpPr txBox="1"/>
+          <p:nvPr/>
+        </p:nvSpPr>
+        <p:spPr>
+          <a:xfrm>
+            <a:off x="640080" y="457200"/>
+            <a:ext cx="7315200" cy="274320"/>
+          </a:xfrm>
+          <a:prstGeom prst="rect">
+            <a:avLst/>
+          </a:prstGeom>
+          <a:noFill/>
+        </p:spPr>
+        <p:txBody>
+          <a:bodyPr wrap="square" anchor="t">
+            <a:noAutofit/>
+          </a:bodyPr>
+          <a:lstStyle/>
+          <a:p>
+            <a:pPr algn="l"/>
+            <a:r>
+              <a:rPr sz="1100" b="1" i="0">
+                <a:solidFill>
+                  <a:srgbClr val="C9A84C"/>
+                </a:solidFill>
+                <a:latin typeface="Arial"/>
+              </a:rPr>
+              <a:t>WHAT'S NEXT</a:t>
+            </a:r>
+          </a:p>
+        </p:txBody>
+      </p:sp>
+      <p:sp>
+        <p:nvSpPr>
+          <p:cNvPr id="4" name="TextBox 3"/>
+          <p:cNvSpPr txBox="1"/>
+          <p:nvPr/>
+        </p:nvSpPr>
+        <p:spPr>
+          <a:xfrm>
+            <a:off x="640080" y="777240"/>
+            <a:ext cx="10911535" cy="1005840"/>
+          </a:xfrm>
+          <a:prstGeom prst="rect">
+            <a:avLst/>
+          </a:prstGeom>
+          <a:noFill/>
+        </p:spPr>
+        <p:txBody>
+          <a:bodyPr wrap="square" anchor="t">
+            <a:noAutofit/>
+          </a:bodyPr>
+          <a:lstStyle/>
+          <a:p>
+            <a:pPr algn="l"/>
+            <a:r>
+              <a:rPr sz="2600" b="0" i="0">
+                <a:solidFill>
+                  <a:srgbClr val="1E2761"/>
+                </a:solidFill>
+                <a:latin typeface="Georgia"/>
+              </a:rPr>
+              <a:t>Scoped, not hidden.</a:t>
+            </a:r>
+          </a:p>
+        </p:txBody>
+      </p:sp>
+      <p:sp>
+        <p:nvSpPr>
+          <p:cNvPr id="5" name="TextBox 4"/>
+          <p:cNvSpPr txBox="1"/>
+          <p:nvPr/>
+        </p:nvSpPr>
+        <p:spPr>
+          <a:xfrm>
+            <a:off x="640080" y="1508760"/>
+            <a:ext cx="10911535" cy="457200"/>
+          </a:xfrm>
+          <a:prstGeom prst="rect">
+            <a:avLst/>
+          </a:prstGeom>
+          <a:noFill/>
+        </p:spPr>
+        <p:txBody>
+          <a:bodyPr wrap="square" anchor="t">
+            <a:noAutofit/>
+          </a:bodyPr>
+          <a:lstStyle/>
+          <a:p>
+            <a:pPr algn="l"/>
+            <a:r>
+              <a:rPr sz="1250" b="0" i="0">
+                <a:solidFill>
+                  <a:srgbClr val="6B6B6B"/>
+                </a:solidFill>
+                <a:latin typeface="Arial"/>
+              </a:rPr>
+              <a:t>A few screens are intentionally stubbed for a later phase rather than rushed — worth knowing for planning purposes.</a:t>
+            </a:r>
+          </a:p>
+        </p:txBody>
+      </p:sp>
+      <p:sp>
+        <p:nvSpPr>
+          <p:cNvPr id="6" name="Rounded Rectangle 5"/>
+          <p:cNvSpPr/>
+          <p:nvPr/>
+        </p:nvSpPr>
+        <p:spPr>
+          <a:xfrm>
+            <a:off x="640080" y="2286000"/>
+            <a:ext cx="5318607" cy="2011680"/>
+          </a:xfrm>
+          <a:prstGeom prst="roundRect">
+            <a:avLst>
+              <a:gd name="adj" fmla="val 6000"/>
+            </a:avLst>
+          </a:prstGeom>
+          <a:solidFill>
+            <a:srgbClr val="FFFFFF"/>
+          </a:solidFill>
+          <a:ln w="9525">
+            <a:solidFill>
+              <a:srgbClr val="E3E1DA"/>
+            </a:solidFill>
+          </a:ln>
+          <a:effectLst/>
+        </p:spPr>
+        <p:style>
+          <a:lnRef idx="1">
+            <a:schemeClr val="accent1"/>
+          </a:lnRef>
+          <a:fillRef idx="3">
+            <a:schemeClr val="accent1"/>
+          </a:fillRef>
+          <a:effectRef idx="2">
+            <a:schemeClr val="accent1"/>
+          </a:effectRef>
+          <a:fontRef idx="minor">
+            <a:schemeClr val="lt1"/>
+          </a:fontRef>
+        </p:style>
+        <p:txBody>
+          <a:bodyPr rtlCol="0" anchor="ctr"/>
+          <a:lstStyle/>
+          <a:p>
+            <a:pPr algn="ctr"/>
+          </a:p>
+        </p:txBody>
+      </p:sp>
+      <p:sp>
+        <p:nvSpPr>
+          <p:cNvPr id="7" name="Rounded Rectangle 6"/>
+          <p:cNvSpPr/>
+          <p:nvPr/>
+        </p:nvSpPr>
+        <p:spPr>
+          <a:xfrm>
+            <a:off x="868680" y="2514600"/>
+            <a:ext cx="636422" cy="256032"/>
+          </a:xfrm>
+          <a:prstGeom prst="roundRect">
+            <a:avLst>
+              <a:gd name="adj" fmla="val 50000"/>
+            </a:avLst>
+          </a:prstGeom>
+          <a:solidFill>
+            <a:srgbClr val="FDF0DD"/>
+          </a:solidFill>
+          <a:ln>
+            <a:noFill/>
+          </a:ln>
+          <a:effectLst/>
+        </p:spPr>
+        <p:style>
+          <a:lnRef idx="1">
+            <a:schemeClr val="accent1"/>
+          </a:lnRef>
+          <a:fillRef idx="3">
+            <a:schemeClr val="accent1"/>
+          </a:fillRef>
+          <a:effectRef idx="2">
+            <a:schemeClr val="accent1"/>
+          </a:effectRef>
+          <a:fontRef idx="minor">
+            <a:schemeClr val="lt1"/>
+          </a:fontRef>
+        </p:style>
+        <p:txBody>
+          <a:bodyPr rtlCol="0" anchor="ctr" lIns="50800" rIns="50800" tIns="12700" bIns="12700">
+            <a:noAutofit/>
+          </a:bodyPr>
+          <a:lstStyle/>
+          <a:p>
+            <a:pPr algn="ctr"/>
+            <a:r>
+              <a:rPr sz="900" b="1">
+                <a:solidFill>
+                  <a:srgbClr val="8A5A12"/>
+                </a:solidFill>
+                <a:latin typeface="Arial"/>
+              </a:rPr>
+              <a:t>PHASE 4</a:t>
+            </a:r>
+          </a:p>
+        </p:txBody>
+      </p:sp>
+      <p:sp>
+        <p:nvSpPr>
+          <p:cNvPr id="8" name="TextBox 7"/>
+          <p:cNvSpPr txBox="1"/>
+          <p:nvPr/>
+        </p:nvSpPr>
+        <p:spPr>
+          <a:xfrm>
+            <a:off x="868680" y="2971800"/>
+            <a:ext cx="4861407" cy="731520"/>
+          </a:xfrm>
+          <a:prstGeom prst="rect">
+            <a:avLst/>
+          </a:prstGeom>
+          <a:noFill/>
+        </p:spPr>
+        <p:txBody>
+          <a:bodyPr wrap="square" anchor="t">
+            <a:noAutofit/>
+          </a:bodyPr>
+          <a:lstStyle/>
+          <a:p>
+            <a:pPr algn="l">
+              <a:lnSpc>
+                <a:spcPct val="115000"/>
+              </a:lnSpc>
+            </a:pPr>
+            <a:r>
+              <a:rPr sz="1450" b="1" i="0">
+                <a:solidFill>
+                  <a:srgbClr val="1E2761"/>
+                </a:solidFill>
+                <a:latin typeface="Arial"/>
+              </a:rPr>
+              <a:t>Staff leave requests</a:t>
+            </a:r>
+          </a:p>
+        </p:txBody>
+      </p:sp>
+      <p:sp>
+        <p:nvSpPr>
+          <p:cNvPr id="9" name="TextBox 8"/>
+          <p:cNvSpPr txBox="1"/>
+          <p:nvPr/>
+        </p:nvSpPr>
+        <p:spPr>
+          <a:xfrm>
+            <a:off x="868680" y="3703320"/>
+            <a:ext cx="4861407" cy="822960"/>
+          </a:xfrm>
+          <a:prstGeom prst="rect">
+            <a:avLst/>
+          </a:prstGeom>
+          <a:noFill/>
+        </p:spPr>
+        <p:txBody>
+          <a:bodyPr wrap="square" anchor="t">
+            <a:noAutofit/>
+          </a:bodyPr>
+          <a:lstStyle/>
+          <a:p>
+            <a:pPr algn="l">
+              <a:lnSpc>
+                <a:spcPct val="130000"/>
+              </a:lnSpc>
+            </a:pPr>
+            <a:r>
+              <a:rPr sz="1100" b="0" i="0">
+                <a:solidFill>
+                  <a:srgbClr val="6B6B6B"/>
+                </a:solidFill>
+                <a:latin typeface="Arial"/>
+              </a:rPr>
+              <a:t>Let employees submit their own unavailability instead of going through an admin.</a:t>
+            </a:r>
+          </a:p>
+        </p:txBody>
+      </p:sp>
+      <p:sp>
+        <p:nvSpPr>
+          <p:cNvPr id="10" name="Rounded Rectangle 9"/>
+          <p:cNvSpPr/>
+          <p:nvPr/>
+        </p:nvSpPr>
+        <p:spPr>
+          <a:xfrm>
+            <a:off x="6233007" y="2286000"/>
+            <a:ext cx="5318607" cy="2011680"/>
+          </a:xfrm>
+          <a:prstGeom prst="roundRect">
+            <a:avLst>
+              <a:gd name="adj" fmla="val 6000"/>
+            </a:avLst>
+          </a:prstGeom>
+          <a:solidFill>
+            <a:srgbClr val="FFFFFF"/>
+          </a:solidFill>
+          <a:ln w="9525">
+            <a:solidFill>
+              <a:srgbClr val="E3E1DA"/>
+            </a:solidFill>
+          </a:ln>
+          <a:effectLst/>
+        </p:spPr>
+        <p:style>
+          <a:lnRef idx="1">
+            <a:schemeClr val="accent1"/>
+          </a:lnRef>
+          <a:fillRef idx="3">
+            <a:schemeClr val="accent1"/>
+          </a:fillRef>
+          <a:effectRef idx="2">
+            <a:schemeClr val="accent1"/>
+          </a:effectRef>
+          <a:fontRef idx="minor">
+            <a:schemeClr val="lt1"/>
+          </a:fontRef>
+        </p:style>
+        <p:txBody>
+          <a:bodyPr rtlCol="0" anchor="ctr"/>
+          <a:lstStyle/>
+          <a:p>
+            <a:pPr algn="ctr"/>
+          </a:p>
+        </p:txBody>
+      </p:sp>
+      <p:sp>
+        <p:nvSpPr>
+          <p:cNvPr id="11" name="Rounded Rectangle 10"/>
+          <p:cNvSpPr/>
+          <p:nvPr/>
+        </p:nvSpPr>
+        <p:spPr>
+          <a:xfrm>
+            <a:off x="6461607" y="2514600"/>
+            <a:ext cx="636422" cy="256032"/>
+          </a:xfrm>
+          <a:prstGeom prst="roundRect">
+            <a:avLst>
+              <a:gd name="adj" fmla="val 50000"/>
+            </a:avLst>
+          </a:prstGeom>
+          <a:solidFill>
+            <a:srgbClr val="FDF0DD"/>
+          </a:solidFill>
+          <a:ln>
+            <a:noFill/>
+          </a:ln>
+          <a:effectLst/>
+        </p:spPr>
+        <p:style>
+          <a:lnRef idx="1">
+            <a:schemeClr val="accent1"/>
+          </a:lnRef>
+          <a:fillRef idx="3">
+            <a:schemeClr val="accent1"/>
+          </a:fillRef>
+          <a:effectRef idx="2">
+            <a:schemeClr val="accent1"/>
+          </a:effectRef>
+          <a:fontRef idx="minor">
+            <a:schemeClr val="lt1"/>
+          </a:fontRef>
+        </p:style>
+        <p:txBody>
+          <a:bodyPr rtlCol="0" anchor="ctr" lIns="50800" rIns="50800" tIns="12700" bIns="12700">
+            <a:noAutofit/>
+          </a:bodyPr>
+          <a:lstStyle/>
+          <a:p>
+            <a:pPr algn="ctr"/>
+            <a:r>
+              <a:rPr sz="900" b="1">
+                <a:solidFill>
+                  <a:srgbClr val="8A5A12"/>
+                </a:solidFill>
+                <a:latin typeface="Arial"/>
+              </a:rPr>
+              <a:t>PHASE 4</a:t>
+            </a:r>
+          </a:p>
+        </p:txBody>
+      </p:sp>
+      <p:sp>
+        <p:nvSpPr>
+          <p:cNvPr id="12" name="TextBox 11"/>
+          <p:cNvSpPr txBox="1"/>
+          <p:nvPr/>
+        </p:nvSpPr>
+        <p:spPr>
+          <a:xfrm>
+            <a:off x="6461607" y="2971800"/>
+            <a:ext cx="4861407" cy="731520"/>
+          </a:xfrm>
+          <a:prstGeom prst="rect">
+            <a:avLst/>
+          </a:prstGeom>
+          <a:noFill/>
+        </p:spPr>
+        <p:txBody>
+          <a:bodyPr wrap="square" anchor="t">
+            <a:noAutofit/>
+          </a:bodyPr>
+          <a:lstStyle/>
+          <a:p>
+            <a:pPr algn="l">
+              <a:lnSpc>
+                <a:spcPct val="115000"/>
+              </a:lnSpc>
+            </a:pPr>
+            <a:r>
+              <a:rPr sz="1450" b="1" i="0">
+                <a:solidFill>
+                  <a:srgbClr val="1E2761"/>
+                </a:solidFill>
+                <a:latin typeface="Arial"/>
+              </a:rPr>
+              <a:t>Team view for staff</a:t>
+            </a:r>
+          </a:p>
+        </p:txBody>
+      </p:sp>
+      <p:sp>
+        <p:nvSpPr>
+          <p:cNvPr id="13" name="TextBox 12"/>
+          <p:cNvSpPr txBox="1"/>
+          <p:nvPr/>
+        </p:nvSpPr>
+        <p:spPr>
+          <a:xfrm>
+            <a:off x="6461607" y="3703320"/>
+            <a:ext cx="4861407" cy="822960"/>
+          </a:xfrm>
+          <a:prstGeom prst="rect">
+            <a:avLst/>
+          </a:prstGeom>
+          <a:noFill/>
+        </p:spPr>
+        <p:txBody>
+          <a:bodyPr wrap="square" anchor="t">
+            <a:noAutofit/>
+          </a:bodyPr>
+          <a:lstStyle/>
+          <a:p>
+            <a:pPr algn="l">
+              <a:lnSpc>
+                <a:spcPct val="130000"/>
+              </a:lnSpc>
+            </a:pPr>
+            <a:r>
+              <a:rPr sz="1100" b="0" i="0">
+                <a:solidFill>
+                  <a:srgbClr val="6B6B6B"/>
+                </a:solidFill>
+                <a:latin typeface="Arial"/>
+              </a:rPr>
+              <a:t>Let staff see the published roster for their whole boutique, not just their own shifts.</a:t>
+            </a:r>
+          </a:p>
+        </p:txBody>
+      </p:sp>
+    </p:spTree>
+  </p:cSld>
+  <p:clrMapOvr>
+    <a:masterClrMapping/>
+  </p:clrMapOvr>
+</p:sld>
+</file>
+
+<file path=ppt/slides/slide18.xml><?xml version="1.0" encoding="utf-8"?>
+<p:sld xmlns:a="http://schemas.openxmlformats.org/drawingml/2006/main" xmlns:p="http://schemas.openxmlformats.org/presentationml/2006/main" xmlns:r="http://schemas.openxmlformats.org/officeDocument/2006/relationships">
+  <p:cSld>
+    <p:spTree>
+      <p:nvGrpSpPr>
+        <p:cNvPr id="1" name=""/>
+        <p:cNvGrpSpPr/>
+        <p:nvPr/>
+      </p:nvGrpSpPr>
+      <p:grpSpPr/>
+      <p:sp>
+        <p:nvSpPr>
+          <p:cNvPr id="2" name="Rectangle 1"/>
+          <p:cNvSpPr/>
+          <p:nvPr/>
+        </p:nvSpPr>
+        <p:spPr>
+          <a:xfrm>
+            <a:off x="0" y="0"/>
+            <a:ext cx="12191695" cy="6858000"/>
+          </a:xfrm>
+          <a:prstGeom prst="rect">
+            <a:avLst/>
+          </a:prstGeom>
+          <a:solidFill>
             <a:srgbClr val="141D4A"/>
           </a:solidFill>
           <a:ln>
@@ -8347,7 +8512,7 @@
                 </a:solidFill>
                 <a:latin typeface="Arial"/>
               </a:rPr>
-              <a:t>Rebuilt from a single admin screen into three working, role-scoped portals — Admin, Approver and Staff — plus a fourth (Reader, a read-only published-roster browser) reserved for a later phase.</a:t>
+              <a:t>All four role-scoped portals are now live — Admin, Approver, Staff and Reader — each behind its own sign-in. Every user lands directly in the screen built for their job.</a:t>
             </a:r>
           </a:p>
           <a:p>
@@ -8375,7 +8540,7 @@
                 </a:solidFill>
                 <a:latin typeface="Arial"/>
               </a:rPr>
-              <a:t>Every roster moves through the same tracked lifecycle: draft → submitted → approved → published (with reject and amend paths), scored out of 100 by one scoring module shared by the generator and manual edits alike.</a:t>
+              <a:t>Every roster follows the same lifecycle: draft → submitted → approved → published, with reject and amend paths and a full audit trail. One scoring engine judges both automatic generation and manual edits.</a:t>
             </a:r>
           </a:p>
           <a:p>
@@ -8403,7 +8568,7 @@
                 </a:solidFill>
                 <a:latin typeface="Arial"/>
               </a:rPr>
-              <a:t>Staff, VIC clients, shifts, rules and scoring weights are stored per boutique in one data model. The current dataset has two boutiques configured (Sydney and Melbourne); adding another is configuration, not a new build.</a:t>
+              <a:t>Staff, VIC clients, shifts and rules are all configured per boutique in one data model. The current dataset covers two boutiques (Sydney and Melbourne); adding a third is configuration, not new engineering.</a:t>
             </a:r>
           </a:p>
         </p:txBody>
@@ -8565,7 +8730,7 @@
                 </a:solidFill>
                 <a:latin typeface="Arial"/>
               </a:rPr>
-              <a:t>Store or regional operations admins, the manager who signs off each roster, and every floor employee checking their own shifts.</a:t>
+              <a:t>Operations admins, the manager who approves each roster, floor staff checking their shifts, and read-only viewers browsing published rosters.</a:t>
             </a:r>
           </a:p>
         </p:txBody>
@@ -8727,7 +8892,7 @@
                 </a:solidFill>
                 <a:latin typeface="Arial"/>
               </a:rPr>
-              <a:t>Split into four dedicated portals with real sign-in; added submit → approve → publish, live-rescoring manual edits, leave tracking, and per-boutique rules.</a:t>
+              <a:t>The Reader portal shipped — published-roster browsing with CSV/PDF export — completing all four portals.</a:t>
             </a:r>
           </a:p>
         </p:txBody>
@@ -8889,7 +9054,7 @@
                 </a:solidFill>
                 <a:latin typeface="Arial"/>
               </a:rPr>
-              <a:t>One codebase and one data model serve every boutique — scaling to another store is configuration inside the existing schema, not a new build.</a:t>
+              <a:t>One codebase, one data model, every boutique — a new store is configuration, not a rebuild.</a:t>
             </a:r>
           </a:p>
         </p:txBody>
@@ -9854,7 +10019,7 @@
                 </a:solidFill>
                 <a:latin typeface="Arial"/>
               </a:rPr>
-              <a:t>Published view (planned)</a:t>
+              <a:t>Published Rosters</a:t>
             </a:r>
           </a:p>
         </p:txBody>
@@ -9893,7 +10058,7 @@
                 </a:solidFill>
                 <a:latin typeface="Arial"/>
               </a:rPr>
-              <a:t>A read-only, PDF/CSV-exportable roster browser for a shared back-of-house screen or printout.</a:t>
+              <a:t>A read-only roster browser with one-click CSV and PDF export, for a shared back-of-house screen or printout.</a:t>
             </a:r>
           </a:p>
         </p:txBody>

</xml_diff>